<commit_message>
Deck: decision-quality (T9) and americium-transfer slides; contraction figure and compliance analysis accept a third Hamiltonian arm (Ln-xTB); n_atoms fallback fix when mixing older series records
Co-Authored-By: Claude Fable 5.1 <noreply@anthropic.com>
</commit_message>
<xml_diff>
--- a/docs/ACS_talk_2026-08.pptx
+++ b/docs/ACS_talk_2026-08.pptx
@@ -34,6 +34,8 @@
     <p:sldId id="282" r:id="rId34"/>
     <p:sldId id="283" r:id="rId35"/>
     <p:sldId id="284" r:id="rId36"/>
+    <p:sldId id="285" r:id="rId37"/>
+    <p:sldId id="286" r:id="rId38"/>
   </p:sldIdLst>
   <p:sldSz cx="12191695" cy="6858000" type="screen4x3"/>
   <p:notesSz cx="6858000" cy="9144000"/>
@@ -1160,7 +1162,7 @@
           <a:lstStyle/>
           <a:p>
             <a:r>
-              <a:t>I want to flag this because we had it in earlier talks. The 0.53 number was withdrawn inside our own repository by a later analysis and kept being quoted anyway. The honest statement is the middle one: separations are far more reproducible than the levels they come from, there is clearly headroom above 0.33, and we cannot put a number on the limit with this data.</a:t>
+              <a:t>R² undersells the practical value. Panel A: for each adjacent pair, rank the held-out extractants by predicted separation and compare with the measured ranking. Mean Spearman 0.46 over the twelve positions; the predicted top quartile contains a measured top-quartile ligand half of the time, against a quarter by chance. Sm–Eu, Gd–Tb, La–Ce and Yb–Lu rank best; Tb–Dy and Dy–Ho barely above chance. Panel B: split-conformal intervals, calibrated leave-one-extractant-out, cover 79 and 90 percent at nominal 80 and 90, with half-widths of 0.22 and 0.32 log units. Abstaining on uncertain pairs lowers the error but not R², because the confident pairs are the small separations.</a:t>
             </a:r>
           </a:p>
         </p:txBody>
@@ -1230,7 +1232,7 @@
           <a:lstStyle/>
           <a:p>
             <a:r>
-              <a:t>If you take one thing away: on this problem, what you ask the model to predict matters more than what you feed it. And the reason 3D underperforms is not the network — it is that the electronic structure method hands you one number about the metal.</a:t>
+              <a:t>The same database holds 1,815 americium rows, 95 percent on ligands we already model, giving 312 Am/Eu separation factors on 82 extractants under identical conditions — the SANEX chemistry. Left: treating Am as a lanthanide at its radius predicts nothing, which is the right answer, because An/Ln selectivity is soft-donor covalency, not size. Right: with Am rows in training the held-out score is R² 0.47 — but a control that predicts a held-out extractant from the mean of its ligand family scores the same, and within a family the model has no skill. So the model learns which ligand classes separate Am from Eu and in which direction, nothing finer; and the lanthanide target does not move. Same limitation as on the lanthanide side: the descriptors carry the family.</a:t>
             </a:r>
           </a:p>
         </p:txBody>
@@ -1370,7 +1372,7 @@
           <a:lstStyle/>
           <a:p>
             <a:r>
-              <a:t>Questions I expect: (1) why not DFT — cost, 956 complexes times 15 metals; and the point is precisely what the cheap method does to downstream ML. (2) Is +0.008 worth it — on its own, marginal; as evidence about where 3D can act, it is the whole point. (3) Ln-xTB (Zhang 2026) is the obvious third Hamiltonian and we have not run it yet.</a:t>
+              <a:t>I want to flag this because we had it in earlier talks. The 0.53 number was withdrawn inside our own repository by a later analysis and kept being quoted anyway. The honest statement is the middle one: separations are far more reproducible than the levels they come from, there is clearly headroom above 0.33, and we cannot put a number on the limit with this data.</a:t>
             </a:r>
           </a:p>
         </p:txBody>
@@ -1440,7 +1442,7 @@
           <a:lstStyle/>
           <a:p>
             <a:r>
-              <a:t>Leave-extractants-out, 5 folds x 3 repeats. Replicates within a (block, metal) cell are averaged before differencing, so a metal measured ten times does not dominate one measured once.</a:t>
+              <a:t>If you take one thing away: on this problem, what you ask the model to predict matters more than what you feed it. And the reason 3D underperforms is not the network — it is that the electronic structure method hands you one number about the metal.</a:t>
             </a:r>
           </a:p>
         </p:txBody>
@@ -1510,7 +1512,7 @@
           <a:lstStyle/>
           <a:p>
             <a:r>
-              <a:t>Vietoris-Rips complex over the heavy atoms of one complex, with message passing over edges and (for the simplicial variant) triangles, then a metal-shell readout.</a:t>
+              <a:t>Questions I expect: (1) why not DFT — cost, 956 complexes times 15 metals; and the point is precisely what the cheap method does to downstream ML. (2) Is +0.008 worth it — on its own, marginal; as evidence about where 3D can act, it is the whole point. (3) Ln-xTB (Zhang 2026) is the obvious third Hamiltonian and we have not run it yet.</a:t>
             </a:r>
           </a:p>
         </p:txBody>
@@ -1580,7 +1582,7 @@
           <a:lstStyle/>
           <a:p>
             <a:r>
-              <a:t>Full evidence panel: weight curve, nested selection, encoder correlation structure, cross-population gains, seed halves, and the representations that fail in the same slot.</a:t>
+              <a:t>Leave-extractants-out, 5 folds x 3 repeats. Replicates within a (block, metal) cell are averaged before differencing, so a metal measured ten times does not dominate one measured once.</a:t>
             </a:r>
           </a:p>
         </p:txBody>
@@ -1606,6 +1608,146 @@
 </file>
 
 <file path=ppt/notesSlides/notesSlide24.xml><?xml version="1.0" encoding="utf-8"?>
+<p:notes xmlns:a="http://schemas.openxmlformats.org/drawingml/2006/main" xmlns:p="http://schemas.openxmlformats.org/presentationml/2006/main" xmlns:r="http://schemas.openxmlformats.org/officeDocument/2006/relationships">
+  <p:cSld>
+    <p:spTree>
+      <p:nvGrpSpPr>
+        <p:cNvPr id="1" name=""/>
+        <p:cNvGrpSpPr/>
+        <p:nvPr/>
+      </p:nvGrpSpPr>
+      <p:grpSpPr>
+        <a:xfrm>
+          <a:off x="0" y="0"/>
+          <a:ext cx="0" cy="0"/>
+          <a:chOff x="0" y="0"/>
+          <a:chExt cx="0" cy="0"/>
+        </a:xfrm>
+      </p:grpSpPr>
+      <p:sp>
+        <p:nvSpPr>
+          <p:cNvPr id="2" name="Slide Image Placeholder 1"/>
+          <p:cNvSpPr>
+            <a:spLocks noGrp="1"/>
+          </p:cNvSpPr>
+          <p:nvPr>
+            <p:ph type="sldImg" idx="2"/>
+          </p:nvPr>
+        </p:nvSpPr>
+        <p:spPr/>
+      </p:sp>
+      <p:sp>
+        <p:nvSpPr>
+          <p:cNvPr id="3" name="Notes Placeholder 2"/>
+          <p:cNvSpPr>
+            <a:spLocks noGrp="1"/>
+          </p:cNvSpPr>
+          <p:nvPr>
+            <p:ph type="body" idx="3" sz="quarter"/>
+          </p:nvPr>
+        </p:nvSpPr>
+        <p:spPr/>
+        <p:txBody>
+          <a:bodyPr/>
+          <a:lstStyle/>
+          <a:p>
+            <a:r>
+              <a:t>Vietoris-Rips complex over the heavy atoms of one complex, with message passing over edges and (for the simplicial variant) triangles, then a metal-shell readout.</a:t>
+            </a:r>
+          </a:p>
+        </p:txBody>
+      </p:sp>
+      <p:sp>
+        <p:nvSpPr>
+          <p:cNvPr id="4" name="Slide Number Placeholder 3"/>
+          <p:cNvSpPr>
+            <a:spLocks noGrp="1"/>
+          </p:cNvSpPr>
+          <p:nvPr>
+            <p:ph type="sldNum" idx="5" sz="quarter"/>
+          </p:nvPr>
+        </p:nvSpPr>
+        <p:spPr/>
+      </p:sp>
+    </p:spTree>
+  </p:cSld>
+  <p:clrMapOvr>
+    <a:masterClrMapping/>
+  </p:clrMapOvr>
+</p:notes>
+</file>
+
+<file path=ppt/notesSlides/notesSlide25.xml><?xml version="1.0" encoding="utf-8"?>
+<p:notes xmlns:a="http://schemas.openxmlformats.org/drawingml/2006/main" xmlns:p="http://schemas.openxmlformats.org/presentationml/2006/main" xmlns:r="http://schemas.openxmlformats.org/officeDocument/2006/relationships">
+  <p:cSld>
+    <p:spTree>
+      <p:nvGrpSpPr>
+        <p:cNvPr id="1" name=""/>
+        <p:cNvGrpSpPr/>
+        <p:nvPr/>
+      </p:nvGrpSpPr>
+      <p:grpSpPr>
+        <a:xfrm>
+          <a:off x="0" y="0"/>
+          <a:ext cx="0" cy="0"/>
+          <a:chOff x="0" y="0"/>
+          <a:chExt cx="0" cy="0"/>
+        </a:xfrm>
+      </p:grpSpPr>
+      <p:sp>
+        <p:nvSpPr>
+          <p:cNvPr id="2" name="Slide Image Placeholder 1"/>
+          <p:cNvSpPr>
+            <a:spLocks noGrp="1"/>
+          </p:cNvSpPr>
+          <p:nvPr>
+            <p:ph type="sldImg" idx="2"/>
+          </p:nvPr>
+        </p:nvSpPr>
+        <p:spPr/>
+      </p:sp>
+      <p:sp>
+        <p:nvSpPr>
+          <p:cNvPr id="3" name="Notes Placeholder 2"/>
+          <p:cNvSpPr>
+            <a:spLocks noGrp="1"/>
+          </p:cNvSpPr>
+          <p:nvPr>
+            <p:ph type="body" idx="3" sz="quarter"/>
+          </p:nvPr>
+        </p:nvSpPr>
+        <p:spPr/>
+        <p:txBody>
+          <a:bodyPr/>
+          <a:lstStyle/>
+          <a:p>
+            <a:r>
+              <a:t>Full evidence panel: weight curve, nested selection, encoder correlation structure, cross-population gains, seed halves, and the representations that fail in the same slot.</a:t>
+            </a:r>
+          </a:p>
+        </p:txBody>
+      </p:sp>
+      <p:sp>
+        <p:nvSpPr>
+          <p:cNvPr id="4" name="Slide Number Placeholder 3"/>
+          <p:cNvSpPr>
+            <a:spLocks noGrp="1"/>
+          </p:cNvSpPr>
+          <p:nvPr>
+            <p:ph type="sldNum" idx="5" sz="quarter"/>
+          </p:nvPr>
+        </p:nvSpPr>
+        <p:spPr/>
+      </p:sp>
+    </p:spTree>
+  </p:cSld>
+  <p:clrMapOvr>
+    <a:masterClrMapping/>
+  </p:clrMapOvr>
+</p:notes>
+</file>
+
+<file path=ppt/notesSlides/notesSlide26.xml><?xml version="1.0" encoding="utf-8"?>
 <p:notes xmlns:a="http://schemas.openxmlformats.org/drawingml/2006/main" xmlns:p="http://schemas.openxmlformats.org/presentationml/2006/main" xmlns:r="http://schemas.openxmlformats.org/officeDocument/2006/relationships">
   <p:cSld>
     <p:spTree>
@@ -7041,7 +7183,7 @@
         <p:spPr>
           <a:xfrm>
             <a:off x="502920" y="274320"/>
-            <a:ext cx="11247120" cy="822960"/>
+            <a:ext cx="11247120" cy="777240"/>
           </a:xfrm>
           <a:prstGeom prst="rect">
             <a:avLst/>
@@ -7065,21 +7207,45 @@
                   <a:srgbClr val="1A2E4A"/>
                 </a:solidFill>
               </a:rPr>
-              <a:t>What the labels can support — and a claim we had to withdraw</a:t>
-            </a:r>
-          </a:p>
-        </p:txBody>
-      </p:sp>
-      <p:sp>
-        <p:nvSpPr>
-          <p:cNvPr id="3" name="TextBox 2"/>
+              <a:t>What R² = 0.33 buys a screening user: ranking, and honest intervals</a:t>
+            </a:r>
+          </a:p>
+        </p:txBody>
+      </p:sp>
+      <p:pic>
+        <p:nvPicPr>
+          <p:cNvPr id="3" name="Picture 2" descr="T9_ranking.png"/>
+          <p:cNvPicPr>
+            <a:picLocks noChangeAspect="1"/>
+          </p:cNvPicPr>
+          <p:nvPr/>
+        </p:nvPicPr>
+        <p:blipFill>
+          <a:blip r:embed="rId2"/>
+          <a:stretch>
+            <a:fillRect/>
+          </a:stretch>
+        </p:blipFill>
+        <p:spPr>
+          <a:xfrm>
+            <a:off x="780897" y="1188720"/>
+            <a:ext cx="10629900" cy="4800600"/>
+          </a:xfrm>
+          <a:prstGeom prst="rect">
+            <a:avLst/>
+          </a:prstGeom>
+        </p:spPr>
+      </p:pic>
+      <p:sp>
+        <p:nvSpPr>
+          <p:cNvPr id="4" name="TextBox 3"/>
           <p:cNvSpPr txBox="1"/>
           <p:nvPr/>
         </p:nvSpPr>
         <p:spPr>
           <a:xfrm>
-            <a:off x="731520" y="1417320"/>
-            <a:ext cx="10698480" cy="4572000"/>
+            <a:off x="502920" y="6099048"/>
+            <a:ext cx="11247120" cy="548640"/>
           </a:xfrm>
           <a:prstGeom prst="rect">
             <a:avLst/>
@@ -7094,119 +7260,6 @@
           <a:p>
             <a:pPr algn="l">
               <a:lnSpc>
-                <a:spcPct val="125000"/>
-              </a:lnSpc>
-            </a:pPr>
-            <a:r>
-              <a:rPr sz="1800" b="1">
-                <a:solidFill>
-                  <a:srgbClr val="101214"/>
-                </a:solidFill>
-              </a:rPr>
-              <a:t>We previously quoted a ceiling of R² ≈ 0.53. It is not defensible.</a:t>
-            </a:r>
-          </a:p>
-          <a:p>
-            <a:pPr algn="l">
-              <a:lnSpc>
-                <a:spcPct val="125000"/>
-              </a:lnSpc>
-            </a:pPr>
-            <a:r>
-              <a:rPr sz="1500" b="0">
-                <a:solidFill>
-                  <a:srgbClr val="52514E"/>
-                </a:solidFill>
-              </a:rPr>
-              <a:t>The estimator behind it divided the noise of one subset by the variance of a different, wider one; on its own subset it implies a ceiling below the score models already achieve.</a:t>
-            </a:r>
-          </a:p>
-          <a:p>
-            <a:pPr algn="l">
-              <a:lnSpc>
-                <a:spcPct val="125000"/>
-              </a:lnSpc>
-            </a:pPr>
-            <a:r>
-              <a:rPr sz="1800" b="1">
-                <a:solidFill>
-                  <a:srgbClr val="101214"/>
-                </a:solidFill>
-              </a:rPr>
-              <a:t>What is defensible: a separation reproduces to ~0.16 log units.</a:t>
-            </a:r>
-          </a:p>
-          <a:p>
-            <a:pPr algn="l">
-              <a:lnSpc>
-                <a:spcPct val="125000"/>
-              </a:lnSpc>
-            </a:pPr>
-            <a:r>
-              <a:rPr sz="1500" b="0">
-                <a:solidFill>
-                  <a:srgbClr val="52514E"/>
-                </a:solidFill>
-              </a:rPr>
-              <a:t>Measured across independent condition sets, against a spread of ~0.22 — so the noise cancellation on differencing is real, roughly 6× tighter than the levels it is computed from.</a:t>
-            </a:r>
-          </a:p>
-          <a:p>
-            <a:pPr algn="l">
-              <a:lnSpc>
-                <a:spcPct val="125000"/>
-              </a:lnSpc>
-            </a:pPr>
-            <a:r>
-              <a:rPr sz="1800" b="1">
-                <a:solidFill>
-                  <a:srgbClr val="101214"/>
-                </a:solidFill>
-              </a:rPr>
-              <a:t>But no point ceiling is identifiable from this dataset.</a:t>
-            </a:r>
-          </a:p>
-          <a:p>
-            <a:pPr algn="l">
-              <a:lnSpc>
-                <a:spcPct val="125000"/>
-              </a:lnSpc>
-            </a:pPr>
-            <a:r>
-              <a:rPr sz="1500" b="0">
-                <a:solidFill>
-                  <a:srgbClr val="52514E"/>
-                </a:solidFill>
-              </a:rPr>
-              <a:t>70 % of scored pairs come from cells with no replicate at all, and the replicated cells are selected non-randomly. A ceiling needs designed replication, not opportunistic duplicates.</a:t>
-            </a:r>
-          </a:p>
-        </p:txBody>
-      </p:sp>
-      <p:sp>
-        <p:nvSpPr>
-          <p:cNvPr id="4" name="TextBox 3"/>
-          <p:cNvSpPr txBox="1"/>
-          <p:nvPr/>
-        </p:nvSpPr>
-        <p:spPr>
-          <a:xfrm>
-            <a:off x="731520" y="5989320"/>
-            <a:ext cx="10698480" cy="548640"/>
-          </a:xfrm>
-          <a:prstGeom prst="rect">
-            <a:avLst/>
-          </a:prstGeom>
-          <a:noFill/>
-        </p:spPr>
-        <p:txBody>
-          <a:bodyPr wrap="square">
-            <a:spAutoFit/>
-          </a:bodyPr>
-          <a:lstStyle/>
-          <a:p>
-            <a:pPr algn="l">
-              <a:lnSpc>
                 <a:spcPct val="100000"/>
               </a:lnSpc>
             </a:pPr>
@@ -7216,7 +7269,7 @@
                   <a:srgbClr val="52514E"/>
                 </a:solidFill>
               </a:rPr>
-              <a:t>Correcting our own published-in-talks number, before someone else has to.</a:t>
+              <a:t>Ranking held-out extractants doubles the odds of a top-quartile pick; the intervals are calibrated.</a:t>
             </a:r>
           </a:p>
         </p:txBody>
@@ -7248,6 +7301,124 @@
         <p:spPr>
           <a:xfrm>
             <a:off x="502920" y="274320"/>
+            <a:ext cx="11247120" cy="777240"/>
+          </a:xfrm>
+          <a:prstGeom prst="rect">
+            <a:avLst/>
+          </a:prstGeom>
+          <a:noFill/>
+        </p:spPr>
+        <p:txBody>
+          <a:bodyPr wrap="square">
+            <a:spAutoFit/>
+          </a:bodyPr>
+          <a:lstStyle/>
+          <a:p>
+            <a:pPr algn="l">
+              <a:lnSpc>
+                <a:spcPct val="100000"/>
+              </a:lnSpc>
+            </a:pPr>
+            <a:r>
+              <a:rPr sz="2300" b="1">
+                <a:solidFill>
+                  <a:srgbClr val="1A2E4A"/>
+                </a:solidFill>
+              </a:rPr>
+              <a:t>Taking the model to americium: family-level transfer only</a:t>
+            </a:r>
+          </a:p>
+        </p:txBody>
+      </p:sp>
+      <p:pic>
+        <p:nvPicPr>
+          <p:cNvPr id="3" name="Picture 2" descr="am_eu_transfer.png"/>
+          <p:cNvPicPr>
+            <a:picLocks noChangeAspect="1"/>
+          </p:cNvPicPr>
+          <p:nvPr/>
+        </p:nvPicPr>
+        <p:blipFill>
+          <a:blip r:embed="rId2"/>
+          <a:stretch>
+            <a:fillRect/>
+          </a:stretch>
+        </p:blipFill>
+        <p:spPr>
+          <a:xfrm>
+            <a:off x="845191" y="1188720"/>
+            <a:ext cx="10501312" cy="4800600"/>
+          </a:xfrm>
+          <a:prstGeom prst="rect">
+            <a:avLst/>
+          </a:prstGeom>
+        </p:spPr>
+      </p:pic>
+      <p:sp>
+        <p:nvSpPr>
+          <p:cNvPr id="4" name="TextBox 3"/>
+          <p:cNvSpPr txBox="1"/>
+          <p:nvPr/>
+        </p:nvSpPr>
+        <p:spPr>
+          <a:xfrm>
+            <a:off x="502920" y="6099048"/>
+            <a:ext cx="11247120" cy="548640"/>
+          </a:xfrm>
+          <a:prstGeom prst="rect">
+            <a:avLst/>
+          </a:prstGeom>
+          <a:noFill/>
+        </p:spPr>
+        <p:txBody>
+          <a:bodyPr wrap="square">
+            <a:spAutoFit/>
+          </a:bodyPr>
+          <a:lstStyle/>
+          <a:p>
+            <a:pPr algn="l">
+              <a:lnSpc>
+                <a:spcPct val="100000"/>
+              </a:lnSpc>
+            </a:pPr>
+            <a:r>
+              <a:rPr sz="1300" b="0">
+                <a:solidFill>
+                  <a:srgbClr val="52514E"/>
+                </a:solidFill>
+              </a:rPr>
+              <a:t>Zero-shot fails as it should; joint training matches a no-model family lookup (R² 0.47 vs 0.47), within-family R² 0.02.</a:t>
+            </a:r>
+          </a:p>
+        </p:txBody>
+      </p:sp>
+    </p:spTree>
+  </p:cSld>
+  <p:clrMapOvr>
+    <a:masterClrMapping/>
+  </p:clrMapOvr>
+</p:sld>
+</file>
+
+<file path=ppt/slides/slide24.xml><?xml version="1.0" encoding="utf-8"?>
+<p:sld xmlns:a="http://schemas.openxmlformats.org/drawingml/2006/main" xmlns:p="http://schemas.openxmlformats.org/presentationml/2006/main" xmlns:r="http://schemas.openxmlformats.org/officeDocument/2006/relationships">
+  <p:cSld>
+    <p:spTree>
+      <p:nvGrpSpPr>
+        <p:cNvPr id="1" name=""/>
+        <p:cNvGrpSpPr/>
+        <p:nvPr/>
+      </p:nvGrpSpPr>
+      <p:grpSpPr/>
+      <p:sp>
+        <p:nvSpPr>
+          <p:cNvPr id="2" name="TextBox 1"/>
+          <p:cNvSpPr txBox="1"/>
+          <p:nvPr/>
+        </p:nvSpPr>
+        <p:spPr>
+          <a:xfrm>
+            <a:off x="502920" y="274320"/>
             <a:ext cx="11247120" cy="822960"/>
           </a:xfrm>
           <a:prstGeom prst="rect">
@@ -7272,7 +7443,7 @@
                   <a:srgbClr val="1A2E4A"/>
                 </a:solidFill>
               </a:rPr>
-              <a:t>Summary</a:t>
+              <a:t>What the labels can support — and a claim we had to withdraw</a:t>
             </a:r>
           </a:p>
         </p:txBody>
@@ -7310,7 +7481,7 @@
                   <a:srgbClr val="101214"/>
                 </a:solidFill>
               </a:rPr>
-              <a:t>The semiempirical geometries barely encode the contraction.</a:t>
+              <a:t>We previously quoted a ceiling of R² ≈ 0.53. It is not defensible.</a:t>
             </a:r>
           </a:p>
           <a:p>
@@ -7325,7 +7496,7 @@
                   <a:srgbClr val="52514E"/>
                 </a:solidFill>
               </a:rPr>
-              <a:t>GFN2-xTB reproduces 40 % of it; g-xTB is within 8 %. The cause is linear-in-Z parameterisation, and it explains why 3D encoders are interchangeable and why better geometry does not help.</a:t>
+              <a:t>The estimator behind it divided the noise of one subset by the variance of a different, wider one; on its own subset it implies a ceiling below the score models already achieve.</a:t>
             </a:r>
           </a:p>
           <a:p>
@@ -7340,7 +7511,7 @@
                   <a:srgbClr val="101214"/>
                 </a:solidFill>
               </a:rPr>
-              <a:t>Separating level from shape is worth more than any representation change.</a:t>
+              <a:t>What is defensible: a separation reproduces to ~0.16 log units.</a:t>
             </a:r>
           </a:p>
           <a:p>
@@ -7355,7 +7526,7 @@
                   <a:srgbClr val="52514E"/>
                 </a:solidFill>
               </a:rPr>
-              <a:t>+0.268 → +0.318 with the same learner and the same features; that single model beats our previous best combination of three.</a:t>
+              <a:t>Measured across independent condition sets, against a spread of ~0.22 — so the noise cancellation on differencing is real, roughly 6× tighter than the levels it is computed from.</a:t>
             </a:r>
           </a:p>
           <a:p>
@@ -7370,7 +7541,7 @@
                   <a:srgbClr val="101214"/>
                 </a:solidFill>
               </a:rPr>
-              <a:t>3D contributes only through the shape channel: +0.008, confirmed on held-out pairs.</a:t>
+              <a:t>But no point ceiling is identifiable from this dataset.</a:t>
             </a:r>
           </a:p>
           <a:p>
@@ -7385,37 +7556,7 @@
                   <a:srgbClr val="52514E"/>
                 </a:solidFill>
               </a:rPr>
-              <a:t>First configuration in this project where 3D survives next to the strongest tabular model instead of being absorbed by it.</a:t>
-            </a:r>
-          </a:p>
-          <a:p>
-            <a:pPr algn="l">
-              <a:lnSpc>
-                <a:spcPct val="125000"/>
-              </a:lnSpc>
-            </a:pPr>
-            <a:r>
-              <a:rPr sz="1800" b="1">
-                <a:solidFill>
-                  <a:srgbClr val="101214"/>
-                </a:solidFill>
-              </a:rPr>
-              <a:t>Four representation ideas failed, and the controls say why.</a:t>
-            </a:r>
-          </a:p>
-          <a:p>
-            <a:pPr algn="l">
-              <a:lnSpc>
-                <a:spcPct val="125000"/>
-              </a:lnSpc>
-            </a:pPr>
-            <a:r>
-              <a:rPr sz="1500" b="0">
-                <a:solidFill>
-                  <a:srgbClr val="52514E"/>
-                </a:solidFill>
-              </a:rPr>
-              <a:t>Topology is redundant; persistence descriptors inject within-block noise; conditions do not transfer; the energy signal did not replicate.</a:t>
+              <a:t>70 % of scored pairs come from cells with no replicate at all, and the replicated cells are selected non-randomly. A ceiling needs designed replication, not opportunistic duplicates.</a:t>
             </a:r>
           </a:p>
         </p:txBody>
@@ -7453,7 +7594,7 @@
                   <a:srgbClr val="52514E"/>
                 </a:solidFill>
               </a:rPr>
-              <a:t>Next: designed replication for a real ceiling; the under-prediction of large separations; Ln-xTB as a third Hamiltonian.</a:t>
+              <a:t>Correcting our own published-in-talks number, before someone else has to.</a:t>
             </a:r>
           </a:p>
         </p:txBody>
@@ -7466,7 +7607,244 @@
 </p:sld>
 </file>
 
-<file path=ppt/slides/slide24.xml><?xml version="1.0" encoding="utf-8"?>
+<file path=ppt/slides/slide25.xml><?xml version="1.0" encoding="utf-8"?>
+<p:sld xmlns:a="http://schemas.openxmlformats.org/drawingml/2006/main" xmlns:p="http://schemas.openxmlformats.org/presentationml/2006/main" xmlns:r="http://schemas.openxmlformats.org/officeDocument/2006/relationships">
+  <p:cSld>
+    <p:spTree>
+      <p:nvGrpSpPr>
+        <p:cNvPr id="1" name=""/>
+        <p:cNvGrpSpPr/>
+        <p:nvPr/>
+      </p:nvGrpSpPr>
+      <p:grpSpPr/>
+      <p:sp>
+        <p:nvSpPr>
+          <p:cNvPr id="2" name="TextBox 1"/>
+          <p:cNvSpPr txBox="1"/>
+          <p:nvPr/>
+        </p:nvSpPr>
+        <p:spPr>
+          <a:xfrm>
+            <a:off x="502920" y="274320"/>
+            <a:ext cx="11247120" cy="822960"/>
+          </a:xfrm>
+          <a:prstGeom prst="rect">
+            <a:avLst/>
+          </a:prstGeom>
+          <a:noFill/>
+        </p:spPr>
+        <p:txBody>
+          <a:bodyPr wrap="square">
+            <a:spAutoFit/>
+          </a:bodyPr>
+          <a:lstStyle/>
+          <a:p>
+            <a:pPr algn="l">
+              <a:lnSpc>
+                <a:spcPct val="100000"/>
+              </a:lnSpc>
+            </a:pPr>
+            <a:r>
+              <a:rPr sz="2300" b="1">
+                <a:solidFill>
+                  <a:srgbClr val="1A2E4A"/>
+                </a:solidFill>
+              </a:rPr>
+              <a:t>Summary</a:t>
+            </a:r>
+          </a:p>
+        </p:txBody>
+      </p:sp>
+      <p:sp>
+        <p:nvSpPr>
+          <p:cNvPr id="3" name="TextBox 2"/>
+          <p:cNvSpPr txBox="1"/>
+          <p:nvPr/>
+        </p:nvSpPr>
+        <p:spPr>
+          <a:xfrm>
+            <a:off x="731520" y="1417320"/>
+            <a:ext cx="10698480" cy="4572000"/>
+          </a:xfrm>
+          <a:prstGeom prst="rect">
+            <a:avLst/>
+          </a:prstGeom>
+          <a:noFill/>
+        </p:spPr>
+        <p:txBody>
+          <a:bodyPr wrap="square">
+            <a:spAutoFit/>
+          </a:bodyPr>
+          <a:lstStyle/>
+          <a:p>
+            <a:pPr algn="l">
+              <a:lnSpc>
+                <a:spcPct val="125000"/>
+              </a:lnSpc>
+            </a:pPr>
+            <a:r>
+              <a:rPr sz="1800" b="1">
+                <a:solidFill>
+                  <a:srgbClr val="101214"/>
+                </a:solidFill>
+              </a:rPr>
+              <a:t>The semiempirical geometries barely encode the contraction.</a:t>
+            </a:r>
+          </a:p>
+          <a:p>
+            <a:pPr algn="l">
+              <a:lnSpc>
+                <a:spcPct val="125000"/>
+              </a:lnSpc>
+            </a:pPr>
+            <a:r>
+              <a:rPr sz="1500" b="0">
+                <a:solidFill>
+                  <a:srgbClr val="52514E"/>
+                </a:solidFill>
+              </a:rPr>
+              <a:t>GFN2-xTB reproduces 40 % of it; g-xTB is within 8 %. The cause is linear-in-Z parameterisation, and it explains why 3D encoders are interchangeable and why better geometry does not help.</a:t>
+            </a:r>
+          </a:p>
+          <a:p>
+            <a:pPr algn="l">
+              <a:lnSpc>
+                <a:spcPct val="125000"/>
+              </a:lnSpc>
+            </a:pPr>
+            <a:r>
+              <a:rPr sz="1800" b="1">
+                <a:solidFill>
+                  <a:srgbClr val="101214"/>
+                </a:solidFill>
+              </a:rPr>
+              <a:t>Separating level from shape is worth more than any representation change.</a:t>
+            </a:r>
+          </a:p>
+          <a:p>
+            <a:pPr algn="l">
+              <a:lnSpc>
+                <a:spcPct val="125000"/>
+              </a:lnSpc>
+            </a:pPr>
+            <a:r>
+              <a:rPr sz="1500" b="0">
+                <a:solidFill>
+                  <a:srgbClr val="52514E"/>
+                </a:solidFill>
+              </a:rPr>
+              <a:t>+0.268 → +0.318 with the same learner and the same features; that single model beats our previous best combination of three.</a:t>
+            </a:r>
+          </a:p>
+          <a:p>
+            <a:pPr algn="l">
+              <a:lnSpc>
+                <a:spcPct val="125000"/>
+              </a:lnSpc>
+            </a:pPr>
+            <a:r>
+              <a:rPr sz="1800" b="1">
+                <a:solidFill>
+                  <a:srgbClr val="101214"/>
+                </a:solidFill>
+              </a:rPr>
+              <a:t>3D contributes only through the shape channel: +0.008, confirmed on held-out pairs.</a:t>
+            </a:r>
+          </a:p>
+          <a:p>
+            <a:pPr algn="l">
+              <a:lnSpc>
+                <a:spcPct val="125000"/>
+              </a:lnSpc>
+            </a:pPr>
+            <a:r>
+              <a:rPr sz="1500" b="0">
+                <a:solidFill>
+                  <a:srgbClr val="52514E"/>
+                </a:solidFill>
+              </a:rPr>
+              <a:t>First configuration in this project where 3D survives next to the strongest tabular model instead of being absorbed by it.</a:t>
+            </a:r>
+          </a:p>
+          <a:p>
+            <a:pPr algn="l">
+              <a:lnSpc>
+                <a:spcPct val="125000"/>
+              </a:lnSpc>
+            </a:pPr>
+            <a:r>
+              <a:rPr sz="1800" b="1">
+                <a:solidFill>
+                  <a:srgbClr val="101214"/>
+                </a:solidFill>
+              </a:rPr>
+              <a:t>Four representation ideas failed, and the controls say why.</a:t>
+            </a:r>
+          </a:p>
+          <a:p>
+            <a:pPr algn="l">
+              <a:lnSpc>
+                <a:spcPct val="125000"/>
+              </a:lnSpc>
+            </a:pPr>
+            <a:r>
+              <a:rPr sz="1500" b="0">
+                <a:solidFill>
+                  <a:srgbClr val="52514E"/>
+                </a:solidFill>
+              </a:rPr>
+              <a:t>Topology is redundant; persistence descriptors inject within-block noise; conditions do not transfer; the energy signal did not replicate.</a:t>
+            </a:r>
+          </a:p>
+        </p:txBody>
+      </p:sp>
+      <p:sp>
+        <p:nvSpPr>
+          <p:cNvPr id="4" name="TextBox 3"/>
+          <p:cNvSpPr txBox="1"/>
+          <p:nvPr/>
+        </p:nvSpPr>
+        <p:spPr>
+          <a:xfrm>
+            <a:off x="731520" y="5989320"/>
+            <a:ext cx="10698480" cy="548640"/>
+          </a:xfrm>
+          <a:prstGeom prst="rect">
+            <a:avLst/>
+          </a:prstGeom>
+          <a:noFill/>
+        </p:spPr>
+        <p:txBody>
+          <a:bodyPr wrap="square">
+            <a:spAutoFit/>
+          </a:bodyPr>
+          <a:lstStyle/>
+          <a:p>
+            <a:pPr algn="l">
+              <a:lnSpc>
+                <a:spcPct val="100000"/>
+              </a:lnSpc>
+            </a:pPr>
+            <a:r>
+              <a:rPr sz="1300" b="0">
+                <a:solidFill>
+                  <a:srgbClr val="52514E"/>
+                </a:solidFill>
+              </a:rPr>
+              <a:t>Next: designed replication for a real ceiling; the under-prediction of large separations; Ln-xTB as a third Hamiltonian.</a:t>
+            </a:r>
+          </a:p>
+        </p:txBody>
+      </p:sp>
+    </p:spTree>
+  </p:cSld>
+  <p:clrMapOvr>
+    <a:masterClrMapping/>
+  </p:clrMapOvr>
+</p:sld>
+</file>
+
+<file path=ppt/slides/slide26.xml><?xml version="1.0" encoding="utf-8"?>
 <p:sld xmlns:a="http://schemas.openxmlformats.org/drawingml/2006/main" xmlns:p="http://schemas.openxmlformats.org/presentationml/2006/main" xmlns:r="http://schemas.openxmlformats.org/officeDocument/2006/relationships">
   <p:cSld>
     <p:spTree>
@@ -7595,7 +7973,7 @@
 </p:sld>
 </file>
 
-<file path=ppt/slides/slide25.xml><?xml version="1.0" encoding="utf-8"?>
+<file path=ppt/slides/slide27.xml><?xml version="1.0" encoding="utf-8"?>
 <p:sld xmlns:a="http://schemas.openxmlformats.org/drawingml/2006/main" xmlns:p="http://schemas.openxmlformats.org/presentationml/2006/main" xmlns:r="http://schemas.openxmlformats.org/officeDocument/2006/relationships">
   <p:cSld>
     <p:spTree>
@@ -7752,7 +8130,7 @@
 </p:sld>
 </file>
 
-<file path=ppt/slides/slide26.xml><?xml version="1.0" encoding="utf-8"?>
+<file path=ppt/slides/slide28.xml><?xml version="1.0" encoding="utf-8"?>
 <p:sld xmlns:a="http://schemas.openxmlformats.org/drawingml/2006/main" xmlns:p="http://schemas.openxmlformats.org/presentationml/2006/main" xmlns:r="http://schemas.openxmlformats.org/officeDocument/2006/relationships">
   <p:cSld>
     <p:spTree>
@@ -7832,7 +8210,7 @@
 </p:sld>
 </file>
 
-<file path=ppt/slides/slide27.xml><?xml version="1.0" encoding="utf-8"?>
+<file path=ppt/slides/slide29.xml><?xml version="1.0" encoding="utf-8"?>
 <p:sld xmlns:a="http://schemas.openxmlformats.org/drawingml/2006/main" xmlns:p="http://schemas.openxmlformats.org/presentationml/2006/main" xmlns:r="http://schemas.openxmlformats.org/officeDocument/2006/relationships">
   <p:cSld>
     <p:spTree>
@@ -7904,444 +8282,6 @@
           </a:prstGeom>
         </p:spPr>
       </p:pic>
-    </p:spTree>
-  </p:cSld>
-  <p:clrMapOvr>
-    <a:masterClrMapping/>
-  </p:clrMapOvr>
-</p:sld>
-</file>
-
-<file path=ppt/slides/slide28.xml><?xml version="1.0" encoding="utf-8"?>
-<p:sld xmlns:a="http://schemas.openxmlformats.org/drawingml/2006/main" xmlns:p="http://schemas.openxmlformats.org/presentationml/2006/main" xmlns:r="http://schemas.openxmlformats.org/officeDocument/2006/relationships">
-  <p:cSld>
-    <p:spTree>
-      <p:nvGrpSpPr>
-        <p:cNvPr id="1" name=""/>
-        <p:cNvGrpSpPr/>
-        <p:nvPr/>
-      </p:nvGrpSpPr>
-      <p:grpSpPr/>
-      <p:sp>
-        <p:nvSpPr>
-          <p:cNvPr id="2" name="TextBox 1"/>
-          <p:cNvSpPr txBox="1"/>
-          <p:nvPr/>
-        </p:nvSpPr>
-        <p:spPr>
-          <a:xfrm>
-            <a:off x="502920" y="274320"/>
-            <a:ext cx="11247120" cy="777240"/>
-          </a:xfrm>
-          <a:prstGeom prst="rect">
-            <a:avLst/>
-          </a:prstGeom>
-          <a:noFill/>
-        </p:spPr>
-        <p:txBody>
-          <a:bodyPr wrap="square">
-            <a:spAutoFit/>
-          </a:bodyPr>
-          <a:lstStyle/>
-          <a:p>
-            <a:pPr algn="l">
-              <a:lnSpc>
-                <a:spcPct val="100000"/>
-              </a:lnSpc>
-            </a:pPr>
-            <a:r>
-              <a:rPr sz="2300" b="1">
-                <a:solidFill>
-                  <a:srgbClr val="1A2E4A"/>
-                </a:solidFill>
-              </a:rPr>
-              <a:t>Backup: how the mixing weight and the evidence were computed</a:t>
-            </a:r>
-          </a:p>
-        </p:txBody>
-      </p:sp>
-      <p:pic>
-        <p:nvPicPr>
-          <p:cNvPr id="3" name="Picture 2" descr="a2_evidence.png"/>
-          <p:cNvPicPr>
-            <a:picLocks noChangeAspect="1"/>
-          </p:cNvPicPr>
-          <p:nvPr/>
-        </p:nvPicPr>
-        <p:blipFill>
-          <a:blip r:embed="rId2"/>
-          <a:stretch>
-            <a:fillRect/>
-          </a:stretch>
-        </p:blipFill>
-        <p:spPr>
-          <a:xfrm>
-            <a:off x="1735721" y="1188720"/>
-            <a:ext cx="8720253" cy="5257800"/>
-          </a:xfrm>
-          <a:prstGeom prst="rect">
-            <a:avLst/>
-          </a:prstGeom>
-        </p:spPr>
-      </p:pic>
-    </p:spTree>
-  </p:cSld>
-  <p:clrMapOvr>
-    <a:masterClrMapping/>
-  </p:clrMapOvr>
-</p:sld>
-</file>
-
-<file path=ppt/slides/slide29.xml><?xml version="1.0" encoding="utf-8"?>
-<p:sld xmlns:a="http://schemas.openxmlformats.org/drawingml/2006/main" xmlns:p="http://schemas.openxmlformats.org/presentationml/2006/main" xmlns:r="http://schemas.openxmlformats.org/officeDocument/2006/relationships">
-  <p:cSld>
-    <p:spTree>
-      <p:nvGrpSpPr>
-        <p:cNvPr id="1" name=""/>
-        <p:cNvGrpSpPr/>
-        <p:nvPr/>
-      </p:nvGrpSpPr>
-      <p:grpSpPr/>
-      <p:sp>
-        <p:nvSpPr>
-          <p:cNvPr id="2" name="TextBox 1"/>
-          <p:cNvSpPr txBox="1"/>
-          <p:nvPr/>
-        </p:nvSpPr>
-        <p:spPr>
-          <a:xfrm>
-            <a:off x="502920" y="274320"/>
-            <a:ext cx="11247120" cy="777240"/>
-          </a:xfrm>
-          <a:prstGeom prst="rect">
-            <a:avLst/>
-          </a:prstGeom>
-          <a:noFill/>
-        </p:spPr>
-        <p:txBody>
-          <a:bodyPr wrap="square">
-            <a:spAutoFit/>
-          </a:bodyPr>
-          <a:lstStyle/>
-          <a:p>
-            <a:pPr algn="l">
-              <a:lnSpc>
-                <a:spcPct val="100000"/>
-              </a:lnSpc>
-            </a:pPr>
-            <a:r>
-              <a:rPr sz="2300" b="1">
-                <a:solidFill>
-                  <a:srgbClr val="1A2E4A"/>
-                </a:solidFill>
-              </a:rPr>
-              <a:t>Backup: the label-side series shape</a:t>
-            </a:r>
-          </a:p>
-        </p:txBody>
-      </p:sp>
-      <p:graphicFrame>
-        <p:nvGraphicFramePr>
-          <p:cNvPr id="3" name="Table 2"/>
-          <p:cNvGraphicFramePr>
-            <a:graphicFrameLocks noGrp="1"/>
-          </p:cNvGraphicFramePr>
-          <p:nvPr/>
-        </p:nvGraphicFramePr>
-        <p:xfrm>
-          <a:off x="685800" y="1325880"/>
-          <a:ext cx="10789919" cy="2304288"/>
-        </p:xfrm>
-        <a:graphic>
-          <a:graphicData uri="http://schemas.openxmlformats.org/drawingml/2006/table">
-            <a:tbl>
-              <a:tblPr firstRow="1" bandRow="1">
-                <a:tableStyleId>{5C22544A-7EE6-4342-B048-85BDC9FD1C3A}</a:tableStyleId>
-              </a:tblPr>
-              <a:tblGrid>
-                <a:gridCol w="7847214"/>
-                <a:gridCol w="2942705"/>
-              </a:tblGrid>
-              <a:tr h="384048">
-                <a:tc>
-                  <a:txBody>
-                    <a:bodyPr/>
-                    <a:lstStyle/>
-                    <a:p>
-                      <a:pPr algn="l"/>
-                      <a:r>
-                        <a:rPr sz="1400" b="1">
-                          <a:solidFill>
-                            <a:srgbClr val="1A2E4A"/>
-                          </a:solidFill>
-                        </a:rPr>
-                        <a:t>quantity</a:t>
-                      </a:r>
-                    </a:p>
-                  </a:txBody>
-                  <a:tcPr>
-                    <a:solidFill>
-                      <a:srgbClr val="E3E5E8"/>
-                    </a:solidFill>
-                  </a:tcPr>
-                </a:tc>
-                <a:tc>
-                  <a:txBody>
-                    <a:bodyPr/>
-                    <a:lstStyle/>
-                    <a:p>
-                      <a:pPr algn="ctr"/>
-                      <a:r>
-                        <a:rPr sz="1400" b="1">
-                          <a:solidFill>
-                            <a:srgbClr val="1A2E4A"/>
-                          </a:solidFill>
-                        </a:rPr>
-                        <a:t>value</a:t>
-                      </a:r>
-                    </a:p>
-                  </a:txBody>
-                  <a:tcPr>
-                    <a:solidFill>
-                      <a:srgbClr val="E3E5E8"/>
-                    </a:solidFill>
-                  </a:tcPr>
-                </a:tc>
-              </a:tr>
-              <a:tr h="384048">
-                <a:tc>
-                  <a:txBody>
-                    <a:bodyPr/>
-                    <a:lstStyle/>
-                    <a:p>
-                      <a:pPr algn="l"/>
-                      <a:r>
-                        <a:rPr sz="1350" b="0">
-                          <a:solidFill>
-                            <a:srgbClr val="101214"/>
-                          </a:solidFill>
-                        </a:rPr>
-                        <a:t>LOEO R² from pair identity alone</a:t>
-                      </a:r>
-                    </a:p>
-                  </a:txBody>
-                  <a:tcPr>
-                    <a:solidFill>
-                      <a:srgbClr val="FFFFFF"/>
-                    </a:solidFill>
-                  </a:tcPr>
-                </a:tc>
-                <a:tc>
-                  <a:txBody>
-                    <a:bodyPr/>
-                    <a:lstStyle/>
-                    <a:p>
-                      <a:pPr algn="ctr"/>
-                      <a:r>
-                        <a:rPr sz="1350" b="0">
-                          <a:solidFill>
-                            <a:srgbClr val="101214"/>
-                          </a:solidFill>
-                        </a:rPr>
-                        <a:t>+0.066</a:t>
-                      </a:r>
-                    </a:p>
-                  </a:txBody>
-                  <a:tcPr>
-                    <a:solidFill>
-                      <a:srgbClr val="FFFFFF"/>
-                    </a:solidFill>
-                  </a:tcPr>
-                </a:tc>
-              </a:tr>
-              <a:tr h="384048">
-                <a:tc>
-                  <a:txBody>
-                    <a:bodyPr/>
-                    <a:lstStyle/>
-                    <a:p>
-                      <a:pPr algn="l"/>
-                      <a:r>
-                        <a:rPr sz="1350" b="0">
-                          <a:solidFill>
-                            <a:srgbClr val="101214"/>
-                          </a:solidFill>
-                        </a:rPr>
-                        <a:t>split-half reliability of the 12-position profile</a:t>
-                      </a:r>
-                    </a:p>
-                  </a:txBody>
-                  <a:tcPr>
-                    <a:solidFill>
-                      <a:srgbClr val="FFFFFF"/>
-                    </a:solidFill>
-                  </a:tcPr>
-                </a:tc>
-                <a:tc>
-                  <a:txBody>
-                    <a:bodyPr/>
-                    <a:lstStyle/>
-                    <a:p>
-                      <a:pPr algn="ctr"/>
-                      <a:r>
-                        <a:rPr sz="1350" b="0">
-                          <a:solidFill>
-                            <a:srgbClr val="101214"/>
-                          </a:solidFill>
-                        </a:rPr>
-                        <a:t>r = 0.75</a:t>
-                      </a:r>
-                    </a:p>
-                  </a:txBody>
-                  <a:tcPr>
-                    <a:solidFill>
-                      <a:srgbClr val="FFFFFF"/>
-                    </a:solidFill>
-                  </a:tcPr>
-                </a:tc>
-              </a:tr>
-              <a:tr h="384048">
-                <a:tc>
-                  <a:txBody>
-                    <a:bodyPr/>
-                    <a:lstStyle/>
-                    <a:p>
-                      <a:pPr algn="l"/>
-                      <a:r>
-                        <a:rPr sz="1350" b="0">
-                          <a:solidFill>
-                            <a:srgbClr val="101214"/>
-                          </a:solidFill>
-                        </a:rPr>
-                        <a:t>structure beyond a radius ramp</a:t>
-                      </a:r>
-                    </a:p>
-                  </a:txBody>
-                  <a:tcPr>
-                    <a:solidFill>
-                      <a:srgbClr val="FFFFFF"/>
-                    </a:solidFill>
-                  </a:tcPr>
-                </a:tc>
-                <a:tc>
-                  <a:txBody>
-                    <a:bodyPr/>
-                    <a:lstStyle/>
-                    <a:p>
-                      <a:pPr algn="ctr"/>
-                      <a:r>
-                        <a:rPr sz="1350" b="0">
-                          <a:solidFill>
-                            <a:srgbClr val="101214"/>
-                          </a:solidFill>
-                        </a:rPr>
-                        <a:t>p = 2 × 10⁻¹³</a:t>
-                      </a:r>
-                    </a:p>
-                  </a:txBody>
-                  <a:tcPr>
-                    <a:solidFill>
-                      <a:srgbClr val="FFFFFF"/>
-                    </a:solidFill>
-                  </a:tcPr>
-                </a:tc>
-              </a:tr>
-              <a:tr h="384048">
-                <a:tc>
-                  <a:txBody>
-                    <a:bodyPr/>
-                    <a:lstStyle/>
-                    <a:p>
-                      <a:pPr algn="l"/>
-                      <a:r>
-                        <a:rPr sz="1350" b="0">
-                          <a:solidFill>
-                            <a:srgbClr val="101214"/>
-                          </a:solidFill>
-                        </a:rPr>
-                        <a:t>only positive mean position</a:t>
-                      </a:r>
-                    </a:p>
-                  </a:txBody>
-                  <a:tcPr>
-                    <a:solidFill>
-                      <a:srgbClr val="FFFFFF"/>
-                    </a:solidFill>
-                  </a:tcPr>
-                </a:tc>
-                <a:tc>
-                  <a:txBody>
-                    <a:bodyPr/>
-                    <a:lstStyle/>
-                    <a:p>
-                      <a:pPr algn="ctr"/>
-                      <a:r>
-                        <a:rPr sz="1350" b="0">
-                          <a:solidFill>
-                            <a:srgbClr val="101214"/>
-                          </a:solidFill>
-                        </a:rPr>
-                        <a:t>Eu–Gd</a:t>
-                      </a:r>
-                    </a:p>
-                  </a:txBody>
-                  <a:tcPr>
-                    <a:solidFill>
-                      <a:srgbClr val="FFFFFF"/>
-                    </a:solidFill>
-                  </a:tcPr>
-                </a:tc>
-              </a:tr>
-              <a:tr h="384048">
-                <a:tc>
-                  <a:txBody>
-                    <a:bodyPr/>
-                    <a:lstStyle/>
-                    <a:p>
-                      <a:pPr algn="l"/>
-                      <a:r>
-                        <a:rPr sz="1350" b="0">
-                          <a:solidFill>
-                            <a:srgbClr val="101214"/>
-                          </a:solidFill>
-                        </a:rPr>
-                        <a:t>largest negative position</a:t>
-                      </a:r>
-                    </a:p>
-                  </a:txBody>
-                  <a:tcPr>
-                    <a:solidFill>
-                      <a:srgbClr val="FFFFFF"/>
-                    </a:solidFill>
-                  </a:tcPr>
-                </a:tc>
-                <a:tc>
-                  <a:txBody>
-                    <a:bodyPr/>
-                    <a:lstStyle/>
-                    <a:p>
-                      <a:pPr algn="ctr"/>
-                      <a:r>
-                        <a:rPr sz="1350" b="0">
-                          <a:solidFill>
-                            <a:srgbClr val="101214"/>
-                          </a:solidFill>
-                        </a:rPr>
-                        <a:t>Gd–Tb</a:t>
-                      </a:r>
-                    </a:p>
-                  </a:txBody>
-                  <a:tcPr>
-                    <a:solidFill>
-                      <a:srgbClr val="FFFFFF"/>
-                    </a:solidFill>
-                  </a:tcPr>
-                </a:tc>
-              </a:tr>
-            </a:tbl>
-          </a:graphicData>
-        </a:graphic>
-      </p:graphicFrame>
     </p:spTree>
   </p:cSld>
   <p:clrMapOvr>
@@ -8784,6 +8724,444 @@
           </a:p>
         </p:txBody>
       </p:sp>
+    </p:spTree>
+  </p:cSld>
+  <p:clrMapOvr>
+    <a:masterClrMapping/>
+  </p:clrMapOvr>
+</p:sld>
+</file>
+
+<file path=ppt/slides/slide30.xml><?xml version="1.0" encoding="utf-8"?>
+<p:sld xmlns:a="http://schemas.openxmlformats.org/drawingml/2006/main" xmlns:p="http://schemas.openxmlformats.org/presentationml/2006/main" xmlns:r="http://schemas.openxmlformats.org/officeDocument/2006/relationships">
+  <p:cSld>
+    <p:spTree>
+      <p:nvGrpSpPr>
+        <p:cNvPr id="1" name=""/>
+        <p:cNvGrpSpPr/>
+        <p:nvPr/>
+      </p:nvGrpSpPr>
+      <p:grpSpPr/>
+      <p:sp>
+        <p:nvSpPr>
+          <p:cNvPr id="2" name="TextBox 1"/>
+          <p:cNvSpPr txBox="1"/>
+          <p:nvPr/>
+        </p:nvSpPr>
+        <p:spPr>
+          <a:xfrm>
+            <a:off x="502920" y="274320"/>
+            <a:ext cx="11247120" cy="777240"/>
+          </a:xfrm>
+          <a:prstGeom prst="rect">
+            <a:avLst/>
+          </a:prstGeom>
+          <a:noFill/>
+        </p:spPr>
+        <p:txBody>
+          <a:bodyPr wrap="square">
+            <a:spAutoFit/>
+          </a:bodyPr>
+          <a:lstStyle/>
+          <a:p>
+            <a:pPr algn="l">
+              <a:lnSpc>
+                <a:spcPct val="100000"/>
+              </a:lnSpc>
+            </a:pPr>
+            <a:r>
+              <a:rPr sz="2300" b="1">
+                <a:solidFill>
+                  <a:srgbClr val="1A2E4A"/>
+                </a:solidFill>
+              </a:rPr>
+              <a:t>Backup: how the mixing weight and the evidence were computed</a:t>
+            </a:r>
+          </a:p>
+        </p:txBody>
+      </p:sp>
+      <p:pic>
+        <p:nvPicPr>
+          <p:cNvPr id="3" name="Picture 2" descr="a2_evidence.png"/>
+          <p:cNvPicPr>
+            <a:picLocks noChangeAspect="1"/>
+          </p:cNvPicPr>
+          <p:nvPr/>
+        </p:nvPicPr>
+        <p:blipFill>
+          <a:blip r:embed="rId2"/>
+          <a:stretch>
+            <a:fillRect/>
+          </a:stretch>
+        </p:blipFill>
+        <p:spPr>
+          <a:xfrm>
+            <a:off x="1735721" y="1188720"/>
+            <a:ext cx="8720253" cy="5257800"/>
+          </a:xfrm>
+          <a:prstGeom prst="rect">
+            <a:avLst/>
+          </a:prstGeom>
+        </p:spPr>
+      </p:pic>
+    </p:spTree>
+  </p:cSld>
+  <p:clrMapOvr>
+    <a:masterClrMapping/>
+  </p:clrMapOvr>
+</p:sld>
+</file>
+
+<file path=ppt/slides/slide31.xml><?xml version="1.0" encoding="utf-8"?>
+<p:sld xmlns:a="http://schemas.openxmlformats.org/drawingml/2006/main" xmlns:p="http://schemas.openxmlformats.org/presentationml/2006/main" xmlns:r="http://schemas.openxmlformats.org/officeDocument/2006/relationships">
+  <p:cSld>
+    <p:spTree>
+      <p:nvGrpSpPr>
+        <p:cNvPr id="1" name=""/>
+        <p:cNvGrpSpPr/>
+        <p:nvPr/>
+      </p:nvGrpSpPr>
+      <p:grpSpPr/>
+      <p:sp>
+        <p:nvSpPr>
+          <p:cNvPr id="2" name="TextBox 1"/>
+          <p:cNvSpPr txBox="1"/>
+          <p:nvPr/>
+        </p:nvSpPr>
+        <p:spPr>
+          <a:xfrm>
+            <a:off x="502920" y="274320"/>
+            <a:ext cx="11247120" cy="777240"/>
+          </a:xfrm>
+          <a:prstGeom prst="rect">
+            <a:avLst/>
+          </a:prstGeom>
+          <a:noFill/>
+        </p:spPr>
+        <p:txBody>
+          <a:bodyPr wrap="square">
+            <a:spAutoFit/>
+          </a:bodyPr>
+          <a:lstStyle/>
+          <a:p>
+            <a:pPr algn="l">
+              <a:lnSpc>
+                <a:spcPct val="100000"/>
+              </a:lnSpc>
+            </a:pPr>
+            <a:r>
+              <a:rPr sz="2300" b="1">
+                <a:solidFill>
+                  <a:srgbClr val="1A2E4A"/>
+                </a:solidFill>
+              </a:rPr>
+              <a:t>Backup: the label-side series shape</a:t>
+            </a:r>
+          </a:p>
+        </p:txBody>
+      </p:sp>
+      <p:graphicFrame>
+        <p:nvGraphicFramePr>
+          <p:cNvPr id="3" name="Table 2"/>
+          <p:cNvGraphicFramePr>
+            <a:graphicFrameLocks noGrp="1"/>
+          </p:cNvGraphicFramePr>
+          <p:nvPr/>
+        </p:nvGraphicFramePr>
+        <p:xfrm>
+          <a:off x="685800" y="1325880"/>
+          <a:ext cx="10789919" cy="2304288"/>
+        </p:xfrm>
+        <a:graphic>
+          <a:graphicData uri="http://schemas.openxmlformats.org/drawingml/2006/table">
+            <a:tbl>
+              <a:tblPr firstRow="1" bandRow="1">
+                <a:tableStyleId>{5C22544A-7EE6-4342-B048-85BDC9FD1C3A}</a:tableStyleId>
+              </a:tblPr>
+              <a:tblGrid>
+                <a:gridCol w="7847214"/>
+                <a:gridCol w="2942705"/>
+              </a:tblGrid>
+              <a:tr h="384048">
+                <a:tc>
+                  <a:txBody>
+                    <a:bodyPr/>
+                    <a:lstStyle/>
+                    <a:p>
+                      <a:pPr algn="l"/>
+                      <a:r>
+                        <a:rPr sz="1400" b="1">
+                          <a:solidFill>
+                            <a:srgbClr val="1A2E4A"/>
+                          </a:solidFill>
+                        </a:rPr>
+                        <a:t>quantity</a:t>
+                      </a:r>
+                    </a:p>
+                  </a:txBody>
+                  <a:tcPr>
+                    <a:solidFill>
+                      <a:srgbClr val="E3E5E8"/>
+                    </a:solidFill>
+                  </a:tcPr>
+                </a:tc>
+                <a:tc>
+                  <a:txBody>
+                    <a:bodyPr/>
+                    <a:lstStyle/>
+                    <a:p>
+                      <a:pPr algn="ctr"/>
+                      <a:r>
+                        <a:rPr sz="1400" b="1">
+                          <a:solidFill>
+                            <a:srgbClr val="1A2E4A"/>
+                          </a:solidFill>
+                        </a:rPr>
+                        <a:t>value</a:t>
+                      </a:r>
+                    </a:p>
+                  </a:txBody>
+                  <a:tcPr>
+                    <a:solidFill>
+                      <a:srgbClr val="E3E5E8"/>
+                    </a:solidFill>
+                  </a:tcPr>
+                </a:tc>
+              </a:tr>
+              <a:tr h="384048">
+                <a:tc>
+                  <a:txBody>
+                    <a:bodyPr/>
+                    <a:lstStyle/>
+                    <a:p>
+                      <a:pPr algn="l"/>
+                      <a:r>
+                        <a:rPr sz="1350" b="0">
+                          <a:solidFill>
+                            <a:srgbClr val="101214"/>
+                          </a:solidFill>
+                        </a:rPr>
+                        <a:t>LOEO R² from pair identity alone</a:t>
+                      </a:r>
+                    </a:p>
+                  </a:txBody>
+                  <a:tcPr>
+                    <a:solidFill>
+                      <a:srgbClr val="FFFFFF"/>
+                    </a:solidFill>
+                  </a:tcPr>
+                </a:tc>
+                <a:tc>
+                  <a:txBody>
+                    <a:bodyPr/>
+                    <a:lstStyle/>
+                    <a:p>
+                      <a:pPr algn="ctr"/>
+                      <a:r>
+                        <a:rPr sz="1350" b="0">
+                          <a:solidFill>
+                            <a:srgbClr val="101214"/>
+                          </a:solidFill>
+                        </a:rPr>
+                        <a:t>+0.066</a:t>
+                      </a:r>
+                    </a:p>
+                  </a:txBody>
+                  <a:tcPr>
+                    <a:solidFill>
+                      <a:srgbClr val="FFFFFF"/>
+                    </a:solidFill>
+                  </a:tcPr>
+                </a:tc>
+              </a:tr>
+              <a:tr h="384048">
+                <a:tc>
+                  <a:txBody>
+                    <a:bodyPr/>
+                    <a:lstStyle/>
+                    <a:p>
+                      <a:pPr algn="l"/>
+                      <a:r>
+                        <a:rPr sz="1350" b="0">
+                          <a:solidFill>
+                            <a:srgbClr val="101214"/>
+                          </a:solidFill>
+                        </a:rPr>
+                        <a:t>split-half reliability of the 12-position profile</a:t>
+                      </a:r>
+                    </a:p>
+                  </a:txBody>
+                  <a:tcPr>
+                    <a:solidFill>
+                      <a:srgbClr val="FFFFFF"/>
+                    </a:solidFill>
+                  </a:tcPr>
+                </a:tc>
+                <a:tc>
+                  <a:txBody>
+                    <a:bodyPr/>
+                    <a:lstStyle/>
+                    <a:p>
+                      <a:pPr algn="ctr"/>
+                      <a:r>
+                        <a:rPr sz="1350" b="0">
+                          <a:solidFill>
+                            <a:srgbClr val="101214"/>
+                          </a:solidFill>
+                        </a:rPr>
+                        <a:t>r = 0.75</a:t>
+                      </a:r>
+                    </a:p>
+                  </a:txBody>
+                  <a:tcPr>
+                    <a:solidFill>
+                      <a:srgbClr val="FFFFFF"/>
+                    </a:solidFill>
+                  </a:tcPr>
+                </a:tc>
+              </a:tr>
+              <a:tr h="384048">
+                <a:tc>
+                  <a:txBody>
+                    <a:bodyPr/>
+                    <a:lstStyle/>
+                    <a:p>
+                      <a:pPr algn="l"/>
+                      <a:r>
+                        <a:rPr sz="1350" b="0">
+                          <a:solidFill>
+                            <a:srgbClr val="101214"/>
+                          </a:solidFill>
+                        </a:rPr>
+                        <a:t>structure beyond a radius ramp</a:t>
+                      </a:r>
+                    </a:p>
+                  </a:txBody>
+                  <a:tcPr>
+                    <a:solidFill>
+                      <a:srgbClr val="FFFFFF"/>
+                    </a:solidFill>
+                  </a:tcPr>
+                </a:tc>
+                <a:tc>
+                  <a:txBody>
+                    <a:bodyPr/>
+                    <a:lstStyle/>
+                    <a:p>
+                      <a:pPr algn="ctr"/>
+                      <a:r>
+                        <a:rPr sz="1350" b="0">
+                          <a:solidFill>
+                            <a:srgbClr val="101214"/>
+                          </a:solidFill>
+                        </a:rPr>
+                        <a:t>p = 2 × 10⁻¹³</a:t>
+                      </a:r>
+                    </a:p>
+                  </a:txBody>
+                  <a:tcPr>
+                    <a:solidFill>
+                      <a:srgbClr val="FFFFFF"/>
+                    </a:solidFill>
+                  </a:tcPr>
+                </a:tc>
+              </a:tr>
+              <a:tr h="384048">
+                <a:tc>
+                  <a:txBody>
+                    <a:bodyPr/>
+                    <a:lstStyle/>
+                    <a:p>
+                      <a:pPr algn="l"/>
+                      <a:r>
+                        <a:rPr sz="1350" b="0">
+                          <a:solidFill>
+                            <a:srgbClr val="101214"/>
+                          </a:solidFill>
+                        </a:rPr>
+                        <a:t>only positive mean position</a:t>
+                      </a:r>
+                    </a:p>
+                  </a:txBody>
+                  <a:tcPr>
+                    <a:solidFill>
+                      <a:srgbClr val="FFFFFF"/>
+                    </a:solidFill>
+                  </a:tcPr>
+                </a:tc>
+                <a:tc>
+                  <a:txBody>
+                    <a:bodyPr/>
+                    <a:lstStyle/>
+                    <a:p>
+                      <a:pPr algn="ctr"/>
+                      <a:r>
+                        <a:rPr sz="1350" b="0">
+                          <a:solidFill>
+                            <a:srgbClr val="101214"/>
+                          </a:solidFill>
+                        </a:rPr>
+                        <a:t>Eu–Gd</a:t>
+                      </a:r>
+                    </a:p>
+                  </a:txBody>
+                  <a:tcPr>
+                    <a:solidFill>
+                      <a:srgbClr val="FFFFFF"/>
+                    </a:solidFill>
+                  </a:tcPr>
+                </a:tc>
+              </a:tr>
+              <a:tr h="384048">
+                <a:tc>
+                  <a:txBody>
+                    <a:bodyPr/>
+                    <a:lstStyle/>
+                    <a:p>
+                      <a:pPr algn="l"/>
+                      <a:r>
+                        <a:rPr sz="1350" b="0">
+                          <a:solidFill>
+                            <a:srgbClr val="101214"/>
+                          </a:solidFill>
+                        </a:rPr>
+                        <a:t>largest negative position</a:t>
+                      </a:r>
+                    </a:p>
+                  </a:txBody>
+                  <a:tcPr>
+                    <a:solidFill>
+                      <a:srgbClr val="FFFFFF"/>
+                    </a:solidFill>
+                  </a:tcPr>
+                </a:tc>
+                <a:tc>
+                  <a:txBody>
+                    <a:bodyPr/>
+                    <a:lstStyle/>
+                    <a:p>
+                      <a:pPr algn="ctr"/>
+                      <a:r>
+                        <a:rPr sz="1350" b="0">
+                          <a:solidFill>
+                            <a:srgbClr val="101214"/>
+                          </a:solidFill>
+                        </a:rPr>
+                        <a:t>Gd–Tb</a:t>
+                      </a:r>
+                    </a:p>
+                  </a:txBody>
+                  <a:tcPr>
+                    <a:solidFill>
+                      <a:srgbClr val="FFFFFF"/>
+                    </a:solidFill>
+                  </a:tcPr>
+                </a:tc>
+              </a:tr>
+            </a:tbl>
+          </a:graphicData>
+        </a:graphic>
+      </p:graphicFrame>
     </p:spTree>
   </p:cSld>
   <p:clrMapOvr>

</xml_diff>